<commit_message>
rebrand: International faculty, AI Trainer & Consultant, full CA title, website
- Roles/bio now say "National & International" ICAI Faculty, not just National
- "AI Trainer" -> "AI Trainer & Consultant" in the credentials line
- "CA" abbreviation spelled out as "Chartered Accountant" (name + credentials)
- Dropped the "July 2021" qualification date from the CA credential
- Added shaileshai.qzz.io to contact info (cover line + About/Contact section)
</commit_message>
<xml_diff>
--- a/Vibe_Coding_Module_Slides.pptx
+++ b/Vibe_Coding_Module_Slides.pptx
@@ -7433,7 +7433,7 @@
                 <a:ea typeface="Arial" pitchFamily="34" charset="-122"/>
                 <a:cs typeface="Arial" pitchFamily="34" charset="-120"/>
               </a:rPr>
-              <a:t>CA Shailesh S Wadhawaniya  ·  A SHAILESH-AI Program — AI Training &amp; Consulting</a:t>
+              <a:t>Chartered Accountant Shailesh S Wadhawaniya  ·  A SHAILESH-AI Program — AI Training &amp; Consulting</a:t>
             </a:r>
             <a:endParaRPr lang="en-US" sz="1100" dirty="0"/>
           </a:p>
@@ -7888,7 +7888,7 @@
                 <a:ea typeface="Arial" pitchFamily="34" charset="-122"/>
                 <a:cs typeface="Arial" pitchFamily="34" charset="-120"/>
               </a:rPr>
-              <a:t>Vibe Coding with Claude Code · CA Shailesh S Wadhawaniya</a:t>
+              <a:t>Vibe Coding with Claude Code · Chartered Accountant Shailesh S Wadhawaniya</a:t>
             </a:r>
             <a:endParaRPr lang="en-US" sz="1000" dirty="0"/>
           </a:p>
@@ -8655,7 +8655,7 @@
                 <a:ea typeface="Arial" pitchFamily="34" charset="-122"/>
                 <a:cs typeface="Arial" pitchFamily="34" charset="-120"/>
               </a:rPr>
-              <a:t>Vibe Coding with Claude Code · CA Shailesh S Wadhawaniya</a:t>
+              <a:t>Vibe Coding with Claude Code · Chartered Accountant Shailesh S Wadhawaniya</a:t>
             </a:r>
             <a:endParaRPr lang="en-US" sz="1000" dirty="0"/>
           </a:p>
@@ -8932,7 +8932,7 @@
                 <a:ea typeface="Arial" pitchFamily="34" charset="-122"/>
                 <a:cs typeface="Arial" pitchFamily="34" charset="-120"/>
               </a:rPr>
-              <a:t>Vibe Coding with Claude Code · CA Shailesh S Wadhawaniya</a:t>
+              <a:t>Vibe Coding with Claude Code · Chartered Accountant Shailesh S Wadhawaniya</a:t>
             </a:r>
             <a:endParaRPr lang="en-US" sz="1000" dirty="0"/>
           </a:p>
@@ -9331,7 +9331,7 @@
                 <a:ea typeface="Arial" pitchFamily="34" charset="-122"/>
                 <a:cs typeface="Arial" pitchFamily="34" charset="-120"/>
               </a:rPr>
-              <a:t>Vibe Coding with Claude Code · CA Shailesh S Wadhawaniya</a:t>
+              <a:t>Vibe Coding with Claude Code · Chartered Accountant Shailesh S Wadhawaniya</a:t>
             </a:r>
             <a:endParaRPr lang="en-US" sz="1000" dirty="0"/>
           </a:p>
@@ -10212,7 +10212,7 @@
                 <a:ea typeface="Arial" pitchFamily="34" charset="-122"/>
                 <a:cs typeface="Arial" pitchFamily="34" charset="-120"/>
               </a:rPr>
-              <a:t>Vibe Coding with Claude Code · CA Shailesh S Wadhawaniya</a:t>
+              <a:t>Vibe Coding with Claude Code · Chartered Accountant Shailesh S Wadhawaniya</a:t>
             </a:r>
             <a:endParaRPr lang="en-US" sz="1000" dirty="0"/>
           </a:p>
@@ -10545,7 +10545,7 @@
                 <a:ea typeface="Arial" pitchFamily="34" charset="-122"/>
                 <a:cs typeface="Arial" pitchFamily="34" charset="-120"/>
               </a:rPr>
-              <a:t>Vibe Coding with Claude Code · CA Shailesh S Wadhawaniya</a:t>
+              <a:t>Vibe Coding with Claude Code · Chartered Accountant Shailesh S Wadhawaniya</a:t>
             </a:r>
             <a:endParaRPr lang="en-US" sz="1000" dirty="0"/>
           </a:p>
@@ -10800,7 +10800,7 @@
                 <a:ea typeface="Arial" pitchFamily="34" charset="-122"/>
                 <a:cs typeface="Arial" pitchFamily="34" charset="-120"/>
               </a:rPr>
-              <a:t>Vibe Coding with Claude Code · CA Shailesh S Wadhawaniya</a:t>
+              <a:t>Vibe Coding with Claude Code · Chartered Accountant Shailesh S Wadhawaniya</a:t>
             </a:r>
             <a:endParaRPr lang="en-US" sz="1000" dirty="0"/>
           </a:p>
@@ -11651,7 +11651,7 @@
                 <a:ea typeface="Arial" pitchFamily="34" charset="-122"/>
                 <a:cs typeface="Arial" pitchFamily="34" charset="-120"/>
               </a:rPr>
-              <a:t>Vibe Coding with Claude Code · CA Shailesh S Wadhawaniya</a:t>
+              <a:t>Vibe Coding with Claude Code · Chartered Accountant Shailesh S Wadhawaniya</a:t>
             </a:r>
             <a:endParaRPr lang="en-US" sz="1000" dirty="0"/>
           </a:p>
@@ -12394,7 +12394,7 @@
                 <a:ea typeface="Arial" pitchFamily="34" charset="-122"/>
                 <a:cs typeface="Arial" pitchFamily="34" charset="-120"/>
               </a:rPr>
-              <a:t>Vibe Coding with Claude Code · CA Shailesh S Wadhawaniya</a:t>
+              <a:t>Vibe Coding with Claude Code · Chartered Accountant Shailesh S Wadhawaniya</a:t>
             </a:r>
             <a:endParaRPr lang="en-US" sz="1000" dirty="0"/>
           </a:p>
@@ -13137,7 +13137,7 @@
                 <a:ea typeface="Arial" pitchFamily="34" charset="-122"/>
                 <a:cs typeface="Arial" pitchFamily="34" charset="-120"/>
               </a:rPr>
-              <a:t>Vibe Coding with Claude Code · CA Shailesh S Wadhawaniya</a:t>
+              <a:t>Vibe Coding with Claude Code · Chartered Accountant Shailesh S Wadhawaniya</a:t>
             </a:r>
             <a:endParaRPr lang="en-US" sz="1000" dirty="0"/>
           </a:p>
@@ -14062,7 +14062,7 @@
                 <a:ea typeface="Arial" pitchFamily="34" charset="-122"/>
                 <a:cs typeface="Arial" pitchFamily="34" charset="-120"/>
               </a:rPr>
-              <a:t>Vibe Coding with Claude Code · CA Shailesh S Wadhawaniya</a:t>
+              <a:t>Vibe Coding with Claude Code · Chartered Accountant Shailesh S Wadhawaniya</a:t>
             </a:r>
             <a:endParaRPr lang="en-US" sz="1000" dirty="0"/>
           </a:p>
@@ -14805,7 +14805,7 @@
                 <a:ea typeface="Arial" pitchFamily="34" charset="-122"/>
                 <a:cs typeface="Arial" pitchFamily="34" charset="-120"/>
               </a:rPr>
-              <a:t>Vibe Coding with Claude Code · CA Shailesh S Wadhawaniya</a:t>
+              <a:t>Vibe Coding with Claude Code · Chartered Accountant Shailesh S Wadhawaniya</a:t>
             </a:r>
             <a:endParaRPr lang="en-US" sz="1000" dirty="0"/>
           </a:p>
@@ -15548,7 +15548,7 @@
                 <a:ea typeface="Arial" pitchFamily="34" charset="-122"/>
                 <a:cs typeface="Arial" pitchFamily="34" charset="-120"/>
               </a:rPr>
-              <a:t>Vibe Coding with Claude Code · CA Shailesh S Wadhawaniya</a:t>
+              <a:t>Vibe Coding with Claude Code · Chartered Accountant Shailesh S Wadhawaniya</a:t>
             </a:r>
             <a:endParaRPr lang="en-US" sz="1000" dirty="0"/>
           </a:p>
@@ -15859,7 +15859,7 @@
                 <a:ea typeface="Arial" pitchFamily="34" charset="-122"/>
                 <a:cs typeface="Arial" pitchFamily="34" charset="-120"/>
               </a:rPr>
-              <a:t>Vibe Coding with Claude Code · CA Shailesh S Wadhawaniya</a:t>
+              <a:t>Vibe Coding with Claude Code · Chartered Accountant Shailesh S Wadhawaniya</a:t>
             </a:r>
             <a:endParaRPr lang="en-US" sz="1000" dirty="0"/>
           </a:p>
@@ -16304,7 +16304,7 @@
                 <a:ea typeface="Arial" pitchFamily="34" charset="-122"/>
                 <a:cs typeface="Arial" pitchFamily="34" charset="-120"/>
               </a:rPr>
-              <a:t>Vibe Coding with Claude Code · CA Shailesh S Wadhawaniya</a:t>
+              <a:t>Vibe Coding with Claude Code · Chartered Accountant Shailesh S Wadhawaniya</a:t>
             </a:r>
             <a:endParaRPr lang="en-US" sz="1000" dirty="0"/>
           </a:p>
@@ -16730,7 +16730,7 @@
                 <a:ea typeface="Arial" pitchFamily="34" charset="-122"/>
                 <a:cs typeface="Arial" pitchFamily="34" charset="-120"/>
               </a:rPr>
-              <a:t>Vibe Coding with Claude Code · CA Shailesh S Wadhawaniya</a:t>
+              <a:t>Vibe Coding with Claude Code · Chartered Accountant Shailesh S Wadhawaniya</a:t>
             </a:r>
             <a:endParaRPr lang="en-US" sz="1000" dirty="0"/>
           </a:p>
@@ -17363,7 +17363,7 @@
                 <a:ea typeface="Arial" pitchFamily="34" charset="-122"/>
                 <a:cs typeface="Arial" pitchFamily="34" charset="-120"/>
               </a:rPr>
-              <a:t>Vibe Coding with Claude Code · CA Shailesh S Wadhawaniya</a:t>
+              <a:t>Vibe Coding with Claude Code · Chartered Accountant Shailesh S Wadhawaniya</a:t>
             </a:r>
             <a:endParaRPr lang="en-US" sz="1000" dirty="0"/>
           </a:p>
@@ -18642,7 +18642,7 @@
                 <a:ea typeface="Arial" pitchFamily="34" charset="-122"/>
                 <a:cs typeface="Arial" pitchFamily="34" charset="-120"/>
               </a:rPr>
-              <a:t>Vibe Coding with Claude Code · CA Shailesh S Wadhawaniya</a:t>
+              <a:t>Vibe Coding with Claude Code · Chartered Accountant Shailesh S Wadhawaniya</a:t>
             </a:r>
             <a:endParaRPr lang="en-US" sz="1000" dirty="0"/>
           </a:p>
@@ -18948,7 +18948,7 @@
                 <a:ea typeface="Arial" pitchFamily="34" charset="-122"/>
                 <a:cs typeface="Arial" pitchFamily="34" charset="-120"/>
               </a:rPr>
-              <a:t>Vibe Coding with Claude Code · CA Shailesh S Wadhawaniya</a:t>
+              <a:t>Vibe Coding with Claude Code · Chartered Accountant Shailesh S Wadhawaniya</a:t>
             </a:r>
             <a:endParaRPr lang="en-US" sz="1000" dirty="0"/>
           </a:p>
@@ -19968,7 +19968,7 @@
                 <a:ea typeface="Arial" pitchFamily="34" charset="-122"/>
                 <a:cs typeface="Arial" pitchFamily="34" charset="-120"/>
               </a:rPr>
-              <a:t>Vibe Coding with Claude Code · CA Shailesh S Wadhawaniya</a:t>
+              <a:t>Vibe Coding with Claude Code · Chartered Accountant Shailesh S Wadhawaniya</a:t>
             </a:r>
             <a:endParaRPr lang="en-US" sz="1000" dirty="0"/>
           </a:p>
@@ -20241,7 +20241,7 @@
                 <a:ea typeface="Arial" pitchFamily="34" charset="-122"/>
                 <a:cs typeface="Arial" pitchFamily="34" charset="-120"/>
               </a:rPr>
-              <a:t>Vibe Coding with Claude Code · CA Shailesh S Wadhawaniya</a:t>
+              <a:t>Vibe Coding with Claude Code · Chartered Accountant Shailesh S Wadhawaniya</a:t>
             </a:r>
             <a:endParaRPr lang="en-US" sz="1000" dirty="0"/>
           </a:p>
@@ -20706,7 +20706,7 @@
                 <a:ea typeface="Arial" pitchFamily="34" charset="-122"/>
                 <a:cs typeface="Arial" pitchFamily="34" charset="-120"/>
               </a:rPr>
-              <a:t>Vibe Coding with Claude Code · CA Shailesh S Wadhawaniya</a:t>
+              <a:t>Vibe Coding with Claude Code · Chartered Accountant Shailesh S Wadhawaniya</a:t>
             </a:r>
             <a:endParaRPr lang="en-US" sz="1000" dirty="0"/>
           </a:p>
@@ -20978,7 +20978,7 @@
                 <a:ea typeface="Arial" pitchFamily="34" charset="-122"/>
                 <a:cs typeface="Arial" pitchFamily="34" charset="-120"/>
               </a:rPr>
-              <a:t>Vibe Coding with Claude Code · CA Shailesh S Wadhawaniya</a:t>
+              <a:t>Vibe Coding with Claude Code · Chartered Accountant Shailesh S Wadhawaniya</a:t>
             </a:r>
             <a:endParaRPr lang="en-US" sz="1000" dirty="0"/>
           </a:p>
@@ -22360,7 +22360,7 @@
                 <a:ea typeface="Arial" pitchFamily="34" charset="-122"/>
                 <a:cs typeface="Arial" pitchFamily="34" charset="-120"/>
               </a:rPr>
-              <a:t>Vibe Coding with Claude Code · CA Shailesh S Wadhawaniya</a:t>
+              <a:t>Vibe Coding with Claude Code · Chartered Accountant Shailesh S Wadhawaniya</a:t>
             </a:r>
             <a:endParaRPr lang="en-US" sz="1000" dirty="0"/>
           </a:p>
@@ -22836,7 +22836,7 @@
                 <a:ea typeface="Arial" pitchFamily="34" charset="-122"/>
                 <a:cs typeface="Arial" pitchFamily="34" charset="-120"/>
               </a:rPr>
-              <a:t>Vibe Coding with Claude Code · CA Shailesh S Wadhawaniya</a:t>
+              <a:t>Vibe Coding with Claude Code · Chartered Accountant Shailesh S Wadhawaniya</a:t>
             </a:r>
             <a:endParaRPr lang="en-US" sz="1000" dirty="0"/>
           </a:p>
@@ -23113,7 +23113,7 @@
                 <a:ea typeface="Arial" pitchFamily="34" charset="-122"/>
                 <a:cs typeface="Arial" pitchFamily="34" charset="-120"/>
               </a:rPr>
-              <a:t>Vibe Coding with Claude Code · CA Shailesh S Wadhawaniya</a:t>
+              <a:t>Vibe Coding with Claude Code · Chartered Accountant Shailesh S Wadhawaniya</a:t>
             </a:r>
             <a:endParaRPr lang="en-US" sz="1000" dirty="0"/>
           </a:p>
@@ -23656,7 +23656,7 @@
                 <a:ea typeface="Arial" pitchFamily="34" charset="-122"/>
                 <a:cs typeface="Arial" pitchFamily="34" charset="-120"/>
               </a:rPr>
-              <a:t>Vibe Coding with Claude Code · CA Shailesh S Wadhawaniya</a:t>
+              <a:t>Vibe Coding with Claude Code · Chartered Accountant Shailesh S Wadhawaniya</a:t>
             </a:r>
             <a:endParaRPr lang="en-US" sz="1000" dirty="0"/>
           </a:p>
@@ -23893,7 +23893,7 @@
                 <a:ea typeface="Arial" pitchFamily="34" charset="-122"/>
                 <a:cs typeface="Arial" pitchFamily="34" charset="-120"/>
               </a:rPr>
-              <a:t>Vibe Coding with Claude Code · CA Shailesh S Wadhawaniya</a:t>
+              <a:t>Vibe Coding with Claude Code · Chartered Accountant Shailesh S Wadhawaniya</a:t>
             </a:r>
             <a:endParaRPr lang="en-US" sz="1000" dirty="0"/>
           </a:p>
@@ -24569,7 +24569,7 @@
                 <a:ea typeface="Arial" pitchFamily="34" charset="-122"/>
                 <a:cs typeface="Arial" pitchFamily="34" charset="-120"/>
               </a:rPr>
-              <a:t>Vibe Coding with Claude Code · CA Shailesh S Wadhawaniya</a:t>
+              <a:t>Vibe Coding with Claude Code · Chartered Accountant Shailesh S Wadhawaniya</a:t>
             </a:r>
             <a:endParaRPr lang="en-US" sz="1000" dirty="0"/>
           </a:p>
@@ -24880,7 +24880,7 @@
                 <a:ea typeface="Arial" pitchFamily="34" charset="-122"/>
                 <a:cs typeface="Arial" pitchFamily="34" charset="-120"/>
               </a:rPr>
-              <a:t>Vibe Coding with Claude Code · CA Shailesh S Wadhawaniya</a:t>
+              <a:t>Vibe Coding with Claude Code · Chartered Accountant Shailesh S Wadhawaniya</a:t>
             </a:r>
             <a:endParaRPr lang="en-US" sz="1000" dirty="0"/>
           </a:p>
@@ -25135,7 +25135,7 @@
                 <a:ea typeface="Arial" pitchFamily="34" charset="-122"/>
                 <a:cs typeface="Arial" pitchFamily="34" charset="-120"/>
               </a:rPr>
-              <a:t>Vibe Coding with Claude Code · CA Shailesh S Wadhawaniya</a:t>
+              <a:t>Vibe Coding with Claude Code · Chartered Accountant Shailesh S Wadhawaniya</a:t>
             </a:r>
             <a:endParaRPr lang="en-US" sz="1000" dirty="0"/>
           </a:p>
@@ -25611,7 +25611,7 @@
                 <a:ea typeface="Arial" pitchFamily="34" charset="-122"/>
                 <a:cs typeface="Arial" pitchFamily="34" charset="-120"/>
               </a:rPr>
-              <a:t>Vibe Coding with Claude Code · CA Shailesh S Wadhawaniya</a:t>
+              <a:t>Vibe Coding with Claude Code · Chartered Accountant Shailesh S Wadhawaniya</a:t>
             </a:r>
             <a:endParaRPr lang="en-US" sz="1000" dirty="0"/>
           </a:p>
@@ -26222,7 +26222,7 @@
                 <a:ea typeface="Arial" pitchFamily="34" charset="-122"/>
                 <a:cs typeface="Arial" pitchFamily="34" charset="-120"/>
               </a:rPr>
-              <a:t>Vibe Coding with Claude Code · CA Shailesh S Wadhawaniya</a:t>
+              <a:t>Vibe Coding with Claude Code · Chartered Accountant Shailesh S Wadhawaniya</a:t>
             </a:r>
             <a:endParaRPr lang="en-US" sz="1000" dirty="0"/>
           </a:p>
@@ -26884,7 +26884,7 @@
                 <a:ea typeface="Arial" pitchFamily="34" charset="-122"/>
                 <a:cs typeface="Arial" pitchFamily="34" charset="-120"/>
               </a:rPr>
-              <a:t>Vibe Coding with Claude Code · CA Shailesh S Wadhawaniya</a:t>
+              <a:t>Vibe Coding with Claude Code · Chartered Accountant Shailesh S Wadhawaniya</a:t>
             </a:r>
             <a:endParaRPr lang="en-US" sz="1000" dirty="0"/>
           </a:p>
@@ -28266,7 +28266,7 @@
                 <a:ea typeface="Arial" pitchFamily="34" charset="-122"/>
                 <a:cs typeface="Arial" pitchFamily="34" charset="-120"/>
               </a:rPr>
-              <a:t>Vibe Coding with Claude Code · CA Shailesh S Wadhawaniya</a:t>
+              <a:t>Vibe Coding with Claude Code · Chartered Accountant Shailesh S Wadhawaniya</a:t>
             </a:r>
             <a:endParaRPr lang="en-US" sz="1000" dirty="0"/>
           </a:p>
@@ -28686,7 +28686,7 @@
                 <a:ea typeface="Arial" pitchFamily="34" charset="-122"/>
                 <a:cs typeface="Arial" pitchFamily="34" charset="-120"/>
               </a:rPr>
-              <a:t>Vibe Coding with Claude Code · CA Shailesh S Wadhawaniya</a:t>
+              <a:t>Vibe Coding with Claude Code · Chartered Accountant Shailesh S Wadhawaniya</a:t>
             </a:r>
             <a:endParaRPr lang="en-US" sz="1000" dirty="0"/>
           </a:p>
@@ -29655,7 +29655,7 @@
                 <a:ea typeface="Arial" pitchFamily="34" charset="-122"/>
                 <a:cs typeface="Arial" pitchFamily="34" charset="-120"/>
               </a:rPr>
-              <a:t>Vibe Coding with Claude Code · CA Shailesh S Wadhawaniya</a:t>
+              <a:t>Vibe Coding with Claude Code · Chartered Accountant Shailesh S Wadhawaniya</a:t>
             </a:r>
             <a:endParaRPr lang="en-US" sz="1000" dirty="0"/>
           </a:p>
@@ -29949,7 +29949,7 @@
                 <a:ea typeface="Arial" pitchFamily="34" charset="-122"/>
                 <a:cs typeface="Arial" pitchFamily="34" charset="-120"/>
               </a:rPr>
-              <a:t>Vibe Coding with Claude Code · CA Shailesh S Wadhawaniya</a:t>
+              <a:t>Vibe Coding with Claude Code · Chartered Accountant Shailesh S Wadhawaniya</a:t>
             </a:r>
             <a:endParaRPr lang="en-US" sz="1000" dirty="0"/>
           </a:p>
@@ -30208,7 +30208,7 @@
                 <a:ea typeface="Arial" pitchFamily="34" charset="-122"/>
                 <a:cs typeface="Arial" pitchFamily="34" charset="-120"/>
               </a:rPr>
-              <a:t>Vibe Coding with Claude Code · CA Shailesh S Wadhawaniya</a:t>
+              <a:t>Vibe Coding with Claude Code · Chartered Accountant Shailesh S Wadhawaniya</a:t>
             </a:r>
             <a:endParaRPr lang="en-US" sz="1000" dirty="0"/>
           </a:p>
@@ -30645,7 +30645,7 @@
                 <a:ea typeface="Arial" pitchFamily="34" charset="-122"/>
                 <a:cs typeface="Arial" pitchFamily="34" charset="-120"/>
               </a:rPr>
-              <a:t>Vibe Coding with Claude Code · CA Shailesh S Wadhawaniya</a:t>
+              <a:t>Vibe Coding with Claude Code · Chartered Accountant Shailesh S Wadhawaniya</a:t>
             </a:r>
             <a:endParaRPr lang="en-US" sz="1000" dirty="0"/>
           </a:p>
@@ -31376,7 +31376,7 @@
                 <a:ea typeface="Arial" pitchFamily="34" charset="-122"/>
                 <a:cs typeface="Arial" pitchFamily="34" charset="-120"/>
               </a:rPr>
-              <a:t>Vibe Coding with Claude Code · CA Shailesh S Wadhawaniya</a:t>
+              <a:t>Vibe Coding with Claude Code · Chartered Accountant Shailesh S Wadhawaniya</a:t>
             </a:r>
             <a:endParaRPr lang="en-US" sz="1000" dirty="0"/>
           </a:p>
@@ -31685,7 +31685,7 @@
                 <a:ea typeface="Arial" pitchFamily="34" charset="-122"/>
                 <a:cs typeface="Arial" pitchFamily="34" charset="-120"/>
               </a:rPr>
-              <a:t>Vibe Coding with Claude Code · CA Shailesh S Wadhawaniya</a:t>
+              <a:t>Vibe Coding with Claude Code · Chartered Accountant Shailesh S Wadhawaniya</a:t>
             </a:r>
             <a:endParaRPr lang="en-US" sz="1000" dirty="0"/>
           </a:p>
@@ -32296,7 +32296,7 @@
                 <a:ea typeface="Arial" pitchFamily="34" charset="-122"/>
                 <a:cs typeface="Arial" pitchFamily="34" charset="-120"/>
               </a:rPr>
-              <a:t>Vibe Coding with Claude Code · CA Shailesh S Wadhawaniya</a:t>
+              <a:t>Vibe Coding with Claude Code · Chartered Accountant Shailesh S Wadhawaniya</a:t>
             </a:r>
             <a:endParaRPr lang="en-US" sz="1000" dirty="0"/>
           </a:p>
@@ -32573,7 +32573,7 @@
                 <a:ea typeface="Arial" pitchFamily="34" charset="-122"/>
                 <a:cs typeface="Arial" pitchFamily="34" charset="-120"/>
               </a:rPr>
-              <a:t>Vibe Coding with Claude Code · CA Shailesh S Wadhawaniya</a:t>
+              <a:t>Vibe Coding with Claude Code · Chartered Accountant Shailesh S Wadhawaniya</a:t>
             </a:r>
             <a:endParaRPr lang="en-US" sz="1000" dirty="0"/>
           </a:p>
@@ -33871,7 +33871,7 @@
                 <a:ea typeface="Arial" pitchFamily="34" charset="-122"/>
                 <a:cs typeface="Arial" pitchFamily="34" charset="-120"/>
               </a:rPr>
-              <a:t>Vibe Coding with Claude Code · CA Shailesh S Wadhawaniya</a:t>
+              <a:t>Vibe Coding with Claude Code · Chartered Accountant Shailesh S Wadhawaniya</a:t>
             </a:r>
             <a:endParaRPr lang="en-US" sz="1000" dirty="0"/>
           </a:p>
@@ -34380,7 +34380,7 @@
                 <a:ea typeface="Arial" pitchFamily="34" charset="-122"/>
                 <a:cs typeface="Arial" pitchFamily="34" charset="-120"/>
               </a:rPr>
-              <a:t>Vibe Coding with Claude Code · CA Shailesh S Wadhawaniya</a:t>
+              <a:t>Vibe Coding with Claude Code · Chartered Accountant Shailesh S Wadhawaniya</a:t>
             </a:r>
             <a:endParaRPr lang="en-US" sz="1000" dirty="0"/>
           </a:p>
@@ -34800,7 +34800,7 @@
                 <a:ea typeface="Arial" pitchFamily="34" charset="-122"/>
                 <a:cs typeface="Arial" pitchFamily="34" charset="-120"/>
               </a:rPr>
-              <a:t>Vibe Coding with Claude Code · CA Shailesh S Wadhawaniya</a:t>
+              <a:t>Vibe Coding with Claude Code · Chartered Accountant Shailesh S Wadhawaniya</a:t>
             </a:r>
             <a:endParaRPr lang="en-US" sz="1000" dirty="0"/>
           </a:p>
@@ -35055,7 +35055,7 @@
                 <a:ea typeface="Arial" pitchFamily="34" charset="-122"/>
                 <a:cs typeface="Arial" pitchFamily="34" charset="-120"/>
               </a:rPr>
-              <a:t>Vibe Coding with Claude Code · CA Shailesh S Wadhawaniya</a:t>
+              <a:t>Vibe Coding with Claude Code · Chartered Accountant Shailesh S Wadhawaniya</a:t>
             </a:r>
             <a:endParaRPr lang="en-US" sz="1000" dirty="0"/>
           </a:p>
@@ -35598,7 +35598,7 @@
                 <a:ea typeface="Arial" pitchFamily="34" charset="-122"/>
                 <a:cs typeface="Arial" pitchFamily="34" charset="-120"/>
               </a:rPr>
-              <a:t>Vibe Coding with Claude Code · CA Shailesh S Wadhawaniya</a:t>
+              <a:t>Vibe Coding with Claude Code · Chartered Accountant Shailesh S Wadhawaniya</a:t>
             </a:r>
             <a:endParaRPr lang="en-US" sz="1000" dirty="0"/>
           </a:p>
@@ -36323,7 +36323,7 @@
                 <a:ea typeface="Arial" pitchFamily="34" charset="-122"/>
                 <a:cs typeface="Arial" pitchFamily="34" charset="-120"/>
               </a:rPr>
-              <a:t>Vibe Coding with Claude Code · CA Shailesh S Wadhawaniya</a:t>
+              <a:t>Vibe Coding with Claude Code · Chartered Accountant Shailesh S Wadhawaniya</a:t>
             </a:r>
             <a:endParaRPr lang="en-US" sz="1000" dirty="0"/>
           </a:p>
@@ -36766,7 +36766,7 @@
                 <a:ea typeface="Arial" pitchFamily="34" charset="-122"/>
                 <a:cs typeface="Arial" pitchFamily="34" charset="-120"/>
               </a:rPr>
-              <a:t>Vibe Coding with Claude Code · CA Shailesh S Wadhawaniya</a:t>
+              <a:t>Vibe Coding with Claude Code · Chartered Accountant Shailesh S Wadhawaniya</a:t>
             </a:r>
             <a:endParaRPr lang="en-US" sz="1000" dirty="0"/>
           </a:p>
@@ -37209,7 +37209,7 @@
                 <a:ea typeface="Arial" pitchFamily="34" charset="-122"/>
                 <a:cs typeface="Arial" pitchFamily="34" charset="-120"/>
               </a:rPr>
-              <a:t>Vibe Coding with Claude Code · CA Shailesh S Wadhawaniya</a:t>
+              <a:t>Vibe Coding with Claude Code · Chartered Accountant Shailesh S Wadhawaniya</a:t>
             </a:r>
             <a:endParaRPr lang="en-US" sz="1000" dirty="0"/>
           </a:p>
@@ -38134,7 +38134,7 @@
                 <a:ea typeface="Arial" pitchFamily="34" charset="-122"/>
                 <a:cs typeface="Arial" pitchFamily="34" charset="-120"/>
               </a:rPr>
-              <a:t>Vibe Coding with Claude Code · CA Shailesh S Wadhawaniya</a:t>
+              <a:t>Vibe Coding with Claude Code · Chartered Accountant Shailesh S Wadhawaniya</a:t>
             </a:r>
             <a:endParaRPr lang="en-US" sz="1000" dirty="0"/>
           </a:p>
@@ -38445,7 +38445,7 @@
                 <a:ea typeface="Arial" pitchFamily="34" charset="-122"/>
                 <a:cs typeface="Arial" pitchFamily="34" charset="-120"/>
               </a:rPr>
-              <a:t>Vibe Coding with Claude Code · CA Shailesh S Wadhawaniya</a:t>
+              <a:t>Vibe Coding with Claude Code · Chartered Accountant Shailesh S Wadhawaniya</a:t>
             </a:r>
             <a:endParaRPr lang="en-US" sz="1000" dirty="0"/>
           </a:p>

</xml_diff>